<commit_message>
Default to blue-duo palette, fix + icon proportions, align customer text
</commit_message>
<xml_diff>
--- a/sample outputs/logo_fetch_demo.pptx
+++ b/sample outputs/logo_fetch_demo.pptx
@@ -3284,14 +3284,58 @@
         </p:nvSpPr>
         <p:spPr>
           <a:xfrm>
-            <a:off x="10102188" y="246888"/>
-            <a:ext cx="310896" cy="310896"/>
+            <a:off x="10157052" y="301752"/>
+            <a:ext cx="201168" cy="201168"/>
           </a:xfrm>
           <a:prstGeom prst="ellipse">
             <a:avLst/>
           </a:prstGeom>
+          <a:noFill/>
+          <a:ln w="25400">
+            <a:solidFill>
+              <a:srgbClr val="1A2330"/>
+            </a:solidFill>
+          </a:ln>
+          <a:effectLst/>
+        </p:spPr>
+        <p:style>
+          <a:lnRef idx="1">
+            <a:schemeClr val="accent1"/>
+          </a:lnRef>
+          <a:fillRef idx="3">
+            <a:schemeClr val="accent1"/>
+          </a:fillRef>
+          <a:effectRef idx="2">
+            <a:schemeClr val="accent1"/>
+          </a:effectRef>
+          <a:fontRef idx="minor">
+            <a:schemeClr val="lt1"/>
+          </a:fontRef>
+        </p:style>
+        <p:txBody>
+          <a:bodyPr rtlCol="0" anchor="ctr"/>
+          <a:lstStyle/>
+          <a:p>
+            <a:pPr algn="ctr"/>
+          </a:p>
+        </p:txBody>
+      </p:sp>
+      <p:sp>
+        <p:nvSpPr>
+          <p:cNvPr id="7" name="Rectangle 6"/>
+          <p:cNvSpPr/>
+          <p:nvPr/>
+        </p:nvSpPr>
+        <p:spPr>
+          <a:xfrm>
+            <a:off x="10209355" y="389260"/>
+            <a:ext cx="96560" cy="26151"/>
+          </a:xfrm>
+          <a:prstGeom prst="rect">
+            <a:avLst/>
+          </a:prstGeom>
           <a:solidFill>
-            <a:srgbClr val="5A6B78"/>
+            <a:srgbClr val="1A2330"/>
           </a:solidFill>
           <a:ln>
             <a:noFill/>
@@ -3322,20 +3366,20 @@
       </p:sp>
       <p:sp>
         <p:nvSpPr>
-          <p:cNvPr id="7" name="Rectangle 6"/>
+          <p:cNvPr id="8" name="Rectangle 7"/>
           <p:cNvSpPr/>
           <p:nvPr/>
         </p:nvSpPr>
         <p:spPr>
           <a:xfrm>
-            <a:off x="10176803" y="385236"/>
-            <a:ext cx="161665" cy="34198"/>
+            <a:off x="10244560" y="354055"/>
+            <a:ext cx="26151" cy="96560"/>
           </a:xfrm>
           <a:prstGeom prst="rect">
             <a:avLst/>
           </a:prstGeom>
           <a:solidFill>
-            <a:srgbClr val="FFFFFF"/>
+            <a:srgbClr val="1A2330"/>
           </a:solidFill>
           <a:ln>
             <a:noFill/>
@@ -3364,53 +3408,9 @@
           </a:p>
         </p:txBody>
       </p:sp>
-      <p:sp>
-        <p:nvSpPr>
-          <p:cNvPr id="8" name="Rectangle 7"/>
-          <p:cNvSpPr/>
-          <p:nvPr/>
-        </p:nvSpPr>
-        <p:spPr>
-          <a:xfrm>
-            <a:off x="10240536" y="321503"/>
-            <a:ext cx="34198" cy="161665"/>
-          </a:xfrm>
-          <a:prstGeom prst="rect">
-            <a:avLst/>
-          </a:prstGeom>
-          <a:solidFill>
-            <a:srgbClr val="FFFFFF"/>
-          </a:solidFill>
-          <a:ln>
-            <a:noFill/>
-          </a:ln>
-          <a:effectLst/>
-        </p:spPr>
-        <p:style>
-          <a:lnRef idx="1">
-            <a:schemeClr val="accent1"/>
-          </a:lnRef>
-          <a:fillRef idx="3">
-            <a:schemeClr val="accent1"/>
-          </a:fillRef>
-          <a:effectRef idx="2">
-            <a:schemeClr val="accent1"/>
-          </a:effectRef>
-          <a:fontRef idx="minor">
-            <a:schemeClr val="lt1"/>
-          </a:fontRef>
-        </p:style>
-        <p:txBody>
-          <a:bodyPr rtlCol="0" anchor="ctr"/>
-          <a:lstStyle/>
-          <a:p>
-            <a:pPr algn="ctr"/>
-          </a:p>
-        </p:txBody>
-      </p:sp>
       <p:pic>
         <p:nvPicPr>
-          <p:cNvPr id="9" name="Picture 8" descr="tmpez691aqq.png"/>
+          <p:cNvPr id="9" name="Picture 8" descr="tmptt8x6s9d.png"/>
           <p:cNvPicPr>
             <a:picLocks noChangeAspect="1"/>
           </p:cNvPicPr>

</xml_diff>